<commit_message>
feat: regenerate agent-365 with LF-stable release generation
- render four voices so release-verify passes on any checkout

🎙️ - Generated by Copilot

Co-authored-by: Copilot <223556219+Copilot@users.noreply.github.com>
</commit_message>
<xml_diff>
--- a/projects/agent-365/release/outputs/deck.pptx
+++ b/projects/agent-365/release/outputs/deck.pptx
@@ -1110,7 +1110,7 @@
         <p:spPr>
           <a:xfrm>
             <a:off x="685800" y="3000000"/>
-            <a:ext cx="9600000" cy="1200000"/>
+            <a:ext cx="9600000" cy="1400000"/>
           </a:xfrm>
           <a:prstGeom prst="rect">
             <a:avLst/>
@@ -1135,7 +1135,7 @@
               </a:spcAft>
             </a:pPr>
             <a:r>
-              <a:rPr lang="en-US" sz="1600">
+              <a:rPr lang="en-US" sz="1800">
                 <a:solidFill>
                   <a:srgbClr val="BCBEC3"/>
                 </a:solidFill>
@@ -1242,7 +1242,7 @@
                   <a:srgbClr val="BCBEC3"/>
                 </a:solidFill>
               </a:rPr>
-              <a:t>agent-365-2026-02-am-michael-kokoro-onnx</a:t>
+              <a:t>agent-365-2026-03-am-michael-kokoro-onnx</a:t>
             </a:r>
           </a:p>
         </p:txBody>
@@ -2729,7 +2729,7 @@
                   <a:srgbClr val="BCBEC3"/>
                 </a:solidFill>
               </a:rPr>
-              <a:t>agent-365-2026-02-am-michael-kokoro-onnx</a:t>
+              <a:t>agent-365-2026-03-am-michael-kokoro-onnx</a:t>
             </a:r>
           </a:p>
         </p:txBody>

</xml_diff>

<commit_message>
feat: regenerate agent-365 with its brand theme
- render four voices with the brand header band, palette and fonts

🎨 - Generated by Copilot

Co-authored-by: Copilot <223556219+Copilot@users.noreply.github.com>
</commit_message>
<xml_diff>
--- a/projects/agent-365/release/outputs/deck.pptx
+++ b/projects/agent-365/release/outputs/deck.pptx
@@ -18,6 +18,16 @@
     <a:defPPr>
       <a:defRPr lang="en-US"/>
     </a:defPPr>
+    <a:lvl1pPr algn="l" defTabSz="914400" marL="0" indent="0">
+      <a:defRPr sz="1800" kern="1200">
+        <a:solidFill>
+          <a:schemeClr val="tx1"/>
+        </a:solidFill>
+        <a:latin typeface="+mn-lt"/>
+        <a:ea typeface="+mn-ea"/>
+        <a:cs typeface="+mn-cs"/>
+      </a:defRPr>
+    </a:lvl1pPr>
   </p:defaultTextStyle>
 </p:presentation>
 </file>
@@ -1015,7 +1025,7 @@
     <p:bg>
       <p:bgPr>
         <a:solidFill>
-          <a:srgbClr val="101828"/>
+          <a:srgbClr val="F4F8FC"/>
         </a:solidFill>
         <a:effectLst/>
       </p:bgPr>
@@ -1029,20 +1039,20 @@
       <p:grpSpPr/>
       <p:sp>
         <p:nvSpPr>
-          <p:cNvPr id="2" name="Accent band"/>
+          <p:cNvPr id="2" name="Brand band"/>
           <p:cNvSpPr/>
           <p:nvPr/>
         </p:nvSpPr>
         <p:spPr>
           <a:xfrm>
             <a:off x="0" y="0"/>
-            <a:ext cx="12192000" cy="91440"/>
+            <a:ext cx="12192000" cy="502920"/>
           </a:xfrm>
           <a:prstGeom prst="rect">
             <a:avLst/>
           </a:prstGeom>
           <a:solidFill>
-            <a:srgbClr val="3B82F6"/>
+            <a:srgbClr val="091F2C"/>
           </a:solidFill>
           <a:ln>
             <a:noFill/>
@@ -1051,14 +1061,36 @@
       </p:sp>
       <p:sp>
         <p:nvSpPr>
-          <p:cNvPr id="3" name="Title"/>
-          <p:cNvSpPr txBox="1"/>
-          <p:nvPr/>
-        </p:nvSpPr>
-        <p:spPr>
-          <a:xfrm>
-            <a:off x="685800" y="900000"/>
-            <a:ext cx="10820400" cy="2000000"/>
+          <p:cNvPr id="3" name="Highlight rule"/>
+          <p:cNvSpPr/>
+          <p:nvPr/>
+        </p:nvSpPr>
+        <p:spPr>
+          <a:xfrm>
+            <a:off x="0" y="502920"/>
+            <a:ext cx="12192000" cy="45720"/>
+          </a:xfrm>
+          <a:prstGeom prst="rect">
+            <a:avLst/>
+          </a:prstGeom>
+          <a:solidFill>
+            <a:srgbClr val="50E6FF"/>
+          </a:solidFill>
+          <a:ln>
+            <a:noFill/>
+          </a:ln>
+        </p:spPr>
+      </p:sp>
+      <p:sp>
+        <p:nvSpPr>
+          <p:cNvPr id="4" name="Deck kicker"/>
+          <p:cNvSpPr txBox="1"/>
+          <p:nvPr/>
+        </p:nvSpPr>
+        <p:spPr>
+          <a:xfrm>
+            <a:off x="685800" y="0"/>
+            <a:ext cx="8400000" cy="502920"/>
           </a:xfrm>
           <a:prstGeom prst="rect">
             <a:avLst/>
@@ -1083,45 +1115,74 @@
               </a:spcAft>
             </a:pPr>
             <a:r>
-              <a:rPr lang="en-US" sz="3700" b="1">
+              <a:rPr lang="en-US" sz="1100" b="1" cap="all" spc="120">
                 <a:solidFill>
                   <a:srgbClr val="FFFFFF"/>
                 </a:solidFill>
               </a:rPr>
-              <a:t>Agent 365:</a:t>
-            </a:r>
-            <a:r>
-              <a:rPr lang="en-US" sz="3700" b="1">
-                <a:solidFill>
-                  <a:srgbClr val="3B82F6"/>
-                </a:solidFill>
-              </a:rPr>
-              <a:t> pilot the control plane first</a:t>
-            </a:r>
-          </a:p>
-        </p:txBody>
-      </p:sp>
-      <p:sp>
-        <p:nvSpPr>
-          <p:cNvPr id="4" name="Summary"/>
-          <p:cNvSpPr txBox="1"/>
-          <p:nvPr/>
-        </p:nvSpPr>
-        <p:spPr>
-          <a:xfrm>
-            <a:off x="685800" y="3000000"/>
-            <a:ext cx="9600000" cy="1400000"/>
-          </a:xfrm>
-          <a:prstGeom prst="rect">
-            <a:avLst/>
-          </a:prstGeom>
-          <a:noFill/>
-          <a:ln>
-            <a:noFill/>
-          </a:ln>
-        </p:spPr>
-        <p:txBody>
-          <a:bodyPr wrap="square" lIns="182880" tIns="91440" rIns="182880" bIns="91440" anchor="t">
+              <a:t>Agent 365</a:t>
+            </a:r>
+          </a:p>
+        </p:txBody>
+      </p:sp>
+      <p:sp>
+        <p:nvSpPr>
+          <p:cNvPr id="5" name="Slide number"/>
+          <p:cNvSpPr txBox="1"/>
+          <p:nvPr/>
+        </p:nvSpPr>
+        <p:spPr>
+          <a:xfrm>
+            <a:off x="9100000" y="0"/>
+            <a:ext cx="2406400" cy="502920"/>
+          </a:xfrm>
+          <a:prstGeom prst="rect">
+            <a:avLst/>
+          </a:prstGeom>
+          <a:noFill/>
+          <a:ln>
+            <a:noFill/>
+          </a:ln>
+        </p:spPr>
+        <p:txBody>
+          <a:bodyPr wrap="square" lIns="182880" tIns="91440" rIns="182880" bIns="91440" anchor="ctr">
+            <a:normAutofit/>
+          </a:bodyPr>
+          <a:lstStyle/>
+          <a:p>
+            <a:pPr algn="r"/>
+            <a:r>
+              <a:rPr lang="en-US" sz="1100" b="1" cap="all" spc="120">
+                <a:solidFill>
+                  <a:srgbClr val="BAC0C4"/>
+                </a:solidFill>
+              </a:rPr>
+              <a:t>1 / 6</a:t>
+            </a:r>
+          </a:p>
+        </p:txBody>
+      </p:sp>
+      <p:sp>
+        <p:nvSpPr>
+          <p:cNvPr id="6" name="Title"/>
+          <p:cNvSpPr txBox="1"/>
+          <p:nvPr/>
+        </p:nvSpPr>
+        <p:spPr>
+          <a:xfrm>
+            <a:off x="685800" y="1100000"/>
+            <a:ext cx="10820400" cy="2000000"/>
+          </a:xfrm>
+          <a:prstGeom prst="rect">
+            <a:avLst/>
+          </a:prstGeom>
+          <a:noFill/>
+          <a:ln>
+            <a:noFill/>
+          </a:ln>
+        </p:spPr>
+        <p:txBody>
+          <a:bodyPr wrap="square" lIns="182880" tIns="91440" rIns="182880" bIns="91440" anchor="ctr">
             <a:normAutofit/>
           </a:bodyPr>
           <a:lstStyle/>
@@ -1135,43 +1196,47 @@
               </a:spcAft>
             </a:pPr>
             <a:r>
-              <a:rPr lang="en-US" sz="1800">
-                <a:solidFill>
-                  <a:srgbClr val="BCBEC3"/>
-                </a:solidFill>
-              </a:rPr>
-              <a:t>Bottom line: use Agent 365 as the control plane for one accountable pilot; verify ownership, access, action traces, licenses, and preview limits before scaling.</a:t>
-            </a:r>
-          </a:p>
-        </p:txBody>
-      </p:sp>
-      <p:sp>
-        <p:nvSpPr>
-          <p:cNvPr id="5" name="Decision"/>
-          <p:cNvSpPr/>
-          <p:nvPr/>
-        </p:nvSpPr>
-        <p:spPr>
-          <a:xfrm>
-            <a:off x="685800" y="4500000"/>
-            <a:ext cx="10820400" cy="1000000"/>
-          </a:xfrm>
-          <a:prstGeom prst="roundRect">
-            <a:avLst>
-              <a:gd name="adj" fmla="val 9000"/>
-            </a:avLst>
-          </a:prstGeom>
-          <a:solidFill>
-            <a:srgbClr val="172949"/>
-          </a:solidFill>
-          <a:ln w="12700">
-            <a:solidFill>
-              <a:srgbClr val="3B82F6"/>
-            </a:solidFill>
-          </a:ln>
-        </p:spPr>
-        <p:txBody>
-          <a:bodyPr wrap="square" lIns="182880" tIns="91440" rIns="182880" bIns="91440" anchor="ctr">
+              <a:rPr lang="en-US" sz="3700" b="1">
+                <a:solidFill>
+                  <a:srgbClr val="071923"/>
+                </a:solidFill>
+                <a:latin typeface="+mj-lt"/>
+              </a:rPr>
+              <a:t>Agent 365:</a:t>
+            </a:r>
+            <a:r>
+              <a:rPr lang="en-US" sz="3700" b="1">
+                <a:solidFill>
+                  <a:srgbClr val="0067B8"/>
+                </a:solidFill>
+                <a:latin typeface="+mj-lt"/>
+              </a:rPr>
+              <a:t> pilot the control plane first</a:t>
+            </a:r>
+          </a:p>
+        </p:txBody>
+      </p:sp>
+      <p:sp>
+        <p:nvSpPr>
+          <p:cNvPr id="7" name="Summary"/>
+          <p:cNvSpPr txBox="1"/>
+          <p:nvPr/>
+        </p:nvSpPr>
+        <p:spPr>
+          <a:xfrm>
+            <a:off x="685800" y="3150000"/>
+            <a:ext cx="9600000" cy="1400000"/>
+          </a:xfrm>
+          <a:prstGeom prst="rect">
+            <a:avLst/>
+          </a:prstGeom>
+          <a:noFill/>
+          <a:ln>
+            <a:noFill/>
+          </a:ln>
+        </p:spPr>
+        <p:txBody>
+          <a:bodyPr wrap="square" lIns="182880" tIns="91440" rIns="182880" bIns="91440" anchor="t">
             <a:normAutofit/>
           </a:bodyPr>
           <a:lstStyle/>
@@ -1185,45 +1250,43 @@
               </a:spcAft>
             </a:pPr>
             <a:r>
-              <a:rPr lang="en-US" sz="1400" b="1">
-                <a:solidFill>
-                  <a:srgbClr val="3B82F6"/>
-                </a:solidFill>
-              </a:rPr>
-              <a:t>DECISION  </a:t>
-            </a:r>
-            <a:r>
-              <a:rPr lang="en-US" sz="2000" b="1">
-                <a:solidFill>
-                  <a:srgbClr val="FFFFFF"/>
-                </a:solidFill>
-              </a:rPr>
-              <a:t>Pilot one accountable agent before scaling governance.</a:t>
-            </a:r>
-          </a:p>
-        </p:txBody>
-      </p:sp>
-      <p:sp>
-        <p:nvSpPr>
-          <p:cNvPr id="6" name="Footer"/>
-          <p:cNvSpPr txBox="1"/>
-          <p:nvPr/>
-        </p:nvSpPr>
-        <p:spPr>
-          <a:xfrm>
-            <a:off x="685800" y="6250000"/>
-            <a:ext cx="9400000" cy="420000"/>
-          </a:xfrm>
-          <a:prstGeom prst="rect">
-            <a:avLst/>
-          </a:prstGeom>
-          <a:noFill/>
-          <a:ln>
-            <a:noFill/>
-          </a:ln>
-        </p:spPr>
-        <p:txBody>
-          <a:bodyPr wrap="square" lIns="182880" tIns="91440" rIns="182880" bIns="91440" anchor="t">
+              <a:rPr lang="en-US" sz="1800">
+                <a:solidFill>
+                  <a:srgbClr val="626C71"/>
+                </a:solidFill>
+              </a:rPr>
+              <a:t>Bottom line: use Agent 365 as the control plane for one accountable pilot; verify ownership, access, action traces, licenses, and preview limits before scaling.</a:t>
+            </a:r>
+          </a:p>
+        </p:txBody>
+      </p:sp>
+      <p:sp>
+        <p:nvSpPr>
+          <p:cNvPr id="8" name="Decision"/>
+          <p:cNvSpPr/>
+          <p:nvPr/>
+        </p:nvSpPr>
+        <p:spPr>
+          <a:xfrm>
+            <a:off x="685800" y="4650000"/>
+            <a:ext cx="10820400" cy="1000000"/>
+          </a:xfrm>
+          <a:prstGeom prst="roundRect">
+            <a:avLst>
+              <a:gd name="adj" fmla="val 6000"/>
+            </a:avLst>
+          </a:prstGeom>
+          <a:solidFill>
+            <a:srgbClr val="E5FBFF"/>
+          </a:solidFill>
+          <a:ln w="12700">
+            <a:solidFill>
+              <a:srgbClr val="328F9E"/>
+            </a:solidFill>
+          </a:ln>
+        </p:spPr>
+        <p:txBody>
+          <a:bodyPr wrap="square" lIns="182880" tIns="91440" rIns="182880" bIns="91440" anchor="ctr">
             <a:normAutofit/>
           </a:bodyPr>
           <a:lstStyle/>
@@ -1237,26 +1300,34 @@
               </a:spcAft>
             </a:pPr>
             <a:r>
-              <a:rPr lang="en-US" sz="1000">
-                <a:solidFill>
-                  <a:srgbClr val="BCBEC3"/>
-                </a:solidFill>
-              </a:rPr>
-              <a:t>agent-365-2026-03-am-michael-kokoro-onnx</a:t>
-            </a:r>
-          </a:p>
-        </p:txBody>
-      </p:sp>
-      <p:sp>
-        <p:nvSpPr>
-          <p:cNvPr id="7" name="Slide number"/>
-          <p:cNvSpPr txBox="1"/>
-          <p:nvPr/>
-        </p:nvSpPr>
-        <p:spPr>
-          <a:xfrm>
-            <a:off x="10100000" y="6250000"/>
-            <a:ext cx="1400000" cy="420000"/>
+              <a:rPr lang="en-US" sz="1400" b="1">
+                <a:solidFill>
+                  <a:srgbClr val="0067B8"/>
+                </a:solidFill>
+              </a:rPr>
+              <a:t>DECISION  </a:t>
+            </a:r>
+            <a:r>
+              <a:rPr lang="en-US" sz="2000" b="1">
+                <a:solidFill>
+                  <a:srgbClr val="071923"/>
+                </a:solidFill>
+              </a:rPr>
+              <a:t>Pilot one accountable agent before scaling governance.</a:t>
+            </a:r>
+          </a:p>
+        </p:txBody>
+      </p:sp>
+      <p:sp>
+        <p:nvSpPr>
+          <p:cNvPr id="9" name="Footer"/>
+          <p:cNvSpPr txBox="1"/>
+          <p:nvPr/>
+        </p:nvSpPr>
+        <p:spPr>
+          <a:xfrm>
+            <a:off x="685800" y="6250000"/>
+            <a:ext cx="10820400" cy="420000"/>
           </a:xfrm>
           <a:prstGeom prst="rect">
             <a:avLst/>
@@ -1272,14 +1343,21 @@
           </a:bodyPr>
           <a:lstStyle/>
           <a:p>
-            <a:pPr algn="r"/>
+            <a:pPr algn="l">
+              <a:lnSpc>
+                <a:spcPct val="105000"/>
+              </a:lnSpc>
+              <a:spcAft>
+                <a:spcPts val="0"/>
+              </a:spcAft>
+            </a:pPr>
             <a:r>
               <a:rPr lang="en-US" sz="1000">
                 <a:solidFill>
-                  <a:srgbClr val="BCBEC3"/>
-                </a:solidFill>
-              </a:rPr>
-              <a:t>1 / 6</a:t>
+                  <a:srgbClr val="626C71"/>
+                </a:solidFill>
+              </a:rPr>
+              <a:t>agent-365-2026-04-am-michael-kokoro-onnx</a:t>
             </a:r>
           </a:p>
         </p:txBody>
@@ -1298,7 +1376,7 @@
     <p:bg>
       <p:bgPr>
         <a:solidFill>
-          <a:srgbClr val="101828"/>
+          <a:srgbClr val="F4F8FC"/>
         </a:solidFill>
         <a:effectLst/>
       </p:bgPr>
@@ -1312,20 +1390,20 @@
       <p:grpSpPr/>
       <p:sp>
         <p:nvSpPr>
-          <p:cNvPr id="2" name="Accent band"/>
+          <p:cNvPr id="2" name="Brand band"/>
           <p:cNvSpPr/>
           <p:nvPr/>
         </p:nvSpPr>
         <p:spPr>
           <a:xfrm>
             <a:off x="0" y="0"/>
-            <a:ext cx="12192000" cy="91440"/>
+            <a:ext cx="12192000" cy="502920"/>
           </a:xfrm>
           <a:prstGeom prst="rect">
             <a:avLst/>
           </a:prstGeom>
           <a:solidFill>
-            <a:srgbClr val="3B82F6"/>
+            <a:srgbClr val="091F2C"/>
           </a:solidFill>
           <a:ln>
             <a:noFill/>
@@ -1334,14 +1412,36 @@
       </p:sp>
       <p:sp>
         <p:nvSpPr>
-          <p:cNvPr id="3" name="Title"/>
-          <p:cNvSpPr txBox="1"/>
-          <p:nvPr/>
-        </p:nvSpPr>
-        <p:spPr>
-          <a:xfrm>
-            <a:off x="685800" y="420000"/>
-            <a:ext cx="10820400" cy="1150000"/>
+          <p:cNvPr id="3" name="Highlight rule"/>
+          <p:cNvSpPr/>
+          <p:nvPr/>
+        </p:nvSpPr>
+        <p:spPr>
+          <a:xfrm>
+            <a:off x="0" y="502920"/>
+            <a:ext cx="12192000" cy="45720"/>
+          </a:xfrm>
+          <a:prstGeom prst="rect">
+            <a:avLst/>
+          </a:prstGeom>
+          <a:solidFill>
+            <a:srgbClr val="50E6FF"/>
+          </a:solidFill>
+          <a:ln>
+            <a:noFill/>
+          </a:ln>
+        </p:spPr>
+      </p:sp>
+      <p:sp>
+        <p:nvSpPr>
+          <p:cNvPr id="4" name="Deck kicker"/>
+          <p:cNvSpPr txBox="1"/>
+          <p:nvPr/>
+        </p:nvSpPr>
+        <p:spPr>
+          <a:xfrm>
+            <a:off x="685800" y="0"/>
+            <a:ext cx="8400000" cy="502920"/>
           </a:xfrm>
           <a:prstGeom prst="rect">
             <a:avLst/>
@@ -1366,45 +1466,74 @@
               </a:spcAft>
             </a:pPr>
             <a:r>
-              <a:rPr lang="en-US" sz="2900" b="1">
+              <a:rPr lang="en-US" sz="1100" b="1" cap="all" spc="120">
                 <a:solidFill>
                   <a:srgbClr val="FFFFFF"/>
                 </a:solidFill>
               </a:rPr>
-              <a:t>1.</a:t>
-            </a:r>
-            <a:r>
-              <a:rPr lang="en-US" sz="2900" b="1">
-                <a:solidFill>
-                  <a:srgbClr val="3B82F6"/>
-                </a:solidFill>
-              </a:rPr>
-              <a:t> Name the control plane</a:t>
-            </a:r>
-          </a:p>
-        </p:txBody>
-      </p:sp>
-      <p:sp>
-        <p:nvSpPr>
-          <p:cNvPr id="4" name="Body"/>
-          <p:cNvSpPr txBox="1"/>
-          <p:nvPr/>
-        </p:nvSpPr>
-        <p:spPr>
-          <a:xfrm>
-            <a:off x="685800" y="1750000"/>
-            <a:ext cx="3900000" cy="3900000"/>
-          </a:xfrm>
-          <a:prstGeom prst="rect">
-            <a:avLst/>
-          </a:prstGeom>
-          <a:noFill/>
-          <a:ln>
-            <a:noFill/>
-          </a:ln>
-        </p:spPr>
-        <p:txBody>
-          <a:bodyPr wrap="square" lIns="182880" tIns="91440" rIns="182880" bIns="91440" anchor="t">
+              <a:t>Agent 365</a:t>
+            </a:r>
+          </a:p>
+        </p:txBody>
+      </p:sp>
+      <p:sp>
+        <p:nvSpPr>
+          <p:cNvPr id="5" name="Slide number"/>
+          <p:cNvSpPr txBox="1"/>
+          <p:nvPr/>
+        </p:nvSpPr>
+        <p:spPr>
+          <a:xfrm>
+            <a:off x="9100000" y="0"/>
+            <a:ext cx="2406400" cy="502920"/>
+          </a:xfrm>
+          <a:prstGeom prst="rect">
+            <a:avLst/>
+          </a:prstGeom>
+          <a:noFill/>
+          <a:ln>
+            <a:noFill/>
+          </a:ln>
+        </p:spPr>
+        <p:txBody>
+          <a:bodyPr wrap="square" lIns="182880" tIns="91440" rIns="182880" bIns="91440" anchor="ctr">
+            <a:normAutofit/>
+          </a:bodyPr>
+          <a:lstStyle/>
+          <a:p>
+            <a:pPr algn="r"/>
+            <a:r>
+              <a:rPr lang="en-US" sz="1100" b="1" cap="all" spc="120">
+                <a:solidFill>
+                  <a:srgbClr val="BAC0C4"/>
+                </a:solidFill>
+              </a:rPr>
+              <a:t>2 / 6</a:t>
+            </a:r>
+          </a:p>
+        </p:txBody>
+      </p:sp>
+      <p:sp>
+        <p:nvSpPr>
+          <p:cNvPr id="6" name="Title"/>
+          <p:cNvSpPr txBox="1"/>
+          <p:nvPr/>
+        </p:nvSpPr>
+        <p:spPr>
+          <a:xfrm>
+            <a:off x="685800" y="700000"/>
+            <a:ext cx="10820400" cy="1150000"/>
+          </a:xfrm>
+          <a:prstGeom prst="rect">
+            <a:avLst/>
+          </a:prstGeom>
+          <a:noFill/>
+          <a:ln>
+            <a:noFill/>
+          </a:ln>
+        </p:spPr>
+        <p:txBody>
+          <a:bodyPr wrap="square" lIns="182880" tIns="91440" rIns="182880" bIns="91440" anchor="ctr">
             <a:normAutofit/>
           </a:bodyPr>
           <a:lstStyle/>
@@ -1418,77 +1547,36 @@
               </a:spcAft>
             </a:pPr>
             <a:r>
-              <a:rPr lang="en-US" sz="2500">
-                <a:solidFill>
-                  <a:srgbClr val="FFFFFF"/>
-                </a:solidFill>
-              </a:rPr>
-              <a:t>Agent 365 is the control plane for AI agents. Ask who owns each one, where it runs, what it can reach, who it affects, and what risk needs action.</a:t>
-            </a:r>
-          </a:p>
-        </p:txBody>
-      </p:sp>
-      <p:sp>
-        <p:nvSpPr>
-          <p:cNvPr id="5" name="Accent rule"/>
-          <p:cNvSpPr/>
-          <p:nvPr/>
-        </p:nvSpPr>
-        <p:spPr>
-          <a:xfrm>
-            <a:off x="548640" y="1800000"/>
-            <a:ext cx="45720" cy="3800000"/>
-          </a:xfrm>
-          <a:prstGeom prst="rect">
-            <a:avLst/>
-          </a:prstGeom>
-          <a:solidFill>
-            <a:srgbClr val="3B82F6"/>
-          </a:solidFill>
-          <a:ln>
-            <a:noFill/>
-          </a:ln>
-        </p:spPr>
-      </p:sp>
-      <p:pic>
-        <p:nvPicPr>
-          <p:cNvPr id="6" name="Asset visual-control-plane" descr="Frame the pilot with ownership, access, and traceability before scale. (mermaid diagram)"/>
-          <p:cNvPicPr>
-            <a:picLocks noChangeAspect="1"/>
-          </p:cNvPicPr>
-          <p:nvPr/>
-        </p:nvPicPr>
-        <p:blipFill>
-          <a:blip r:embed="rIdImage1"/>
-          <a:stretch>
-            <a:fillRect/>
-          </a:stretch>
-        </p:blipFill>
-        <p:spPr>
-          <a:xfrm>
-            <a:off x="5000000" y="2021875"/>
-            <a:ext cx="6500000" cy="3656250"/>
-          </a:xfrm>
-          <a:prstGeom prst="rect">
-            <a:avLst/>
-          </a:prstGeom>
-          <a:ln>
-            <a:solidFill>
-              <a:srgbClr val="D9D9D9"/>
-            </a:solidFill>
-          </a:ln>
-        </p:spPr>
-      </p:pic>
-      <p:sp>
-        <p:nvSpPr>
-          <p:cNvPr id="7" name="Footer"/>
-          <p:cNvSpPr txBox="1"/>
-          <p:nvPr/>
-        </p:nvSpPr>
-        <p:spPr>
-          <a:xfrm>
-            <a:off x="685800" y="6250000"/>
-            <a:ext cx="9400000" cy="420000"/>
+              <a:rPr lang="en-US" sz="2900" b="1">
+                <a:solidFill>
+                  <a:srgbClr val="071923"/>
+                </a:solidFill>
+                <a:latin typeface="+mj-lt"/>
+              </a:rPr>
+              <a:t>1.</a:t>
+            </a:r>
+            <a:r>
+              <a:rPr lang="en-US" sz="2900" b="1">
+                <a:solidFill>
+                  <a:srgbClr val="0067B8"/>
+                </a:solidFill>
+                <a:latin typeface="+mj-lt"/>
+              </a:rPr>
+              <a:t> Name the control plane</a:t>
+            </a:r>
+          </a:p>
+        </p:txBody>
+      </p:sp>
+      <p:sp>
+        <p:nvSpPr>
+          <p:cNvPr id="7" name="Body"/>
+          <p:cNvSpPr txBox="1"/>
+          <p:nvPr/>
+        </p:nvSpPr>
+        <p:spPr>
+          <a:xfrm>
+            <a:off x="685800" y="1950000"/>
+            <a:ext cx="3900000" cy="3900000"/>
           </a:xfrm>
           <a:prstGeom prst="rect">
             <a:avLst/>
@@ -1513,26 +1601,77 @@
               </a:spcAft>
             </a:pPr>
             <a:r>
-              <a:rPr lang="en-US" sz="1000">
-                <a:solidFill>
-                  <a:srgbClr val="BCBEC3"/>
-                </a:solidFill>
-              </a:rPr>
-              <a:t>Sources: Microsoft Agent 365 - Service Descriptions  ·  Microsoft Agent 365 overview  ·  Quickstart: Connect an Existing Agent to Agent 365</a:t>
-            </a:r>
-          </a:p>
-        </p:txBody>
-      </p:sp>
-      <p:sp>
-        <p:nvSpPr>
-          <p:cNvPr id="8" name="Slide number"/>
-          <p:cNvSpPr txBox="1"/>
-          <p:nvPr/>
-        </p:nvSpPr>
-        <p:spPr>
-          <a:xfrm>
-            <a:off x="10100000" y="6250000"/>
-            <a:ext cx="1400000" cy="420000"/>
+              <a:rPr lang="en-US" sz="2500">
+                <a:solidFill>
+                  <a:srgbClr val="071923"/>
+                </a:solidFill>
+              </a:rPr>
+              <a:t>Agent 365 is the control plane for AI agents. Ask who owns each one, where it runs, what it can reach, who it affects, and what risk needs action.</a:t>
+            </a:r>
+          </a:p>
+        </p:txBody>
+      </p:sp>
+      <p:sp>
+        <p:nvSpPr>
+          <p:cNvPr id="8" name="Accent rule"/>
+          <p:cNvSpPr/>
+          <p:nvPr/>
+        </p:nvSpPr>
+        <p:spPr>
+          <a:xfrm>
+            <a:off x="548640" y="2000000"/>
+            <a:ext cx="45720" cy="3800000"/>
+          </a:xfrm>
+          <a:prstGeom prst="rect">
+            <a:avLst/>
+          </a:prstGeom>
+          <a:solidFill>
+            <a:srgbClr val="0067B8"/>
+          </a:solidFill>
+          <a:ln>
+            <a:noFill/>
+          </a:ln>
+        </p:spPr>
+      </p:sp>
+      <p:pic>
+        <p:nvPicPr>
+          <p:cNvPr id="9" name="Asset visual-control-plane" descr="Frame the pilot with ownership, access, and traceability before scale. (mermaid diagram)"/>
+          <p:cNvPicPr>
+            <a:picLocks noChangeAspect="1"/>
+          </p:cNvPicPr>
+          <p:nvPr/>
+        </p:nvPicPr>
+        <p:blipFill>
+          <a:blip r:embed="rIdImage1"/>
+          <a:stretch>
+            <a:fillRect/>
+          </a:stretch>
+        </p:blipFill>
+        <p:spPr>
+          <a:xfrm>
+            <a:off x="5000000" y="2221875"/>
+            <a:ext cx="6500000" cy="3656250"/>
+          </a:xfrm>
+          <a:prstGeom prst="rect">
+            <a:avLst/>
+          </a:prstGeom>
+          <a:ln>
+            <a:solidFill>
+              <a:srgbClr val="D9D9D9"/>
+            </a:solidFill>
+          </a:ln>
+        </p:spPr>
+      </p:pic>
+      <p:sp>
+        <p:nvSpPr>
+          <p:cNvPr id="10" name="Footer"/>
+          <p:cNvSpPr txBox="1"/>
+          <p:nvPr/>
+        </p:nvSpPr>
+        <p:spPr>
+          <a:xfrm>
+            <a:off x="685800" y="6250000"/>
+            <a:ext cx="10820400" cy="420000"/>
           </a:xfrm>
           <a:prstGeom prst="rect">
             <a:avLst/>
@@ -1548,14 +1687,21 @@
           </a:bodyPr>
           <a:lstStyle/>
           <a:p>
-            <a:pPr algn="r"/>
+            <a:pPr algn="l">
+              <a:lnSpc>
+                <a:spcPct val="105000"/>
+              </a:lnSpc>
+              <a:spcAft>
+                <a:spcPts val="0"/>
+              </a:spcAft>
+            </a:pPr>
             <a:r>
               <a:rPr lang="en-US" sz="1000">
                 <a:solidFill>
-                  <a:srgbClr val="BCBEC3"/>
-                </a:solidFill>
-              </a:rPr>
-              <a:t>2 / 6</a:t>
+                  <a:srgbClr val="626C71"/>
+                </a:solidFill>
+              </a:rPr>
+              <a:t>Sources: Microsoft Agent 365 - Service Descriptions  ·  Microsoft Agent 365 overview  ·  Quickstart: Connect an Existing Agent to Agent 365</a:t>
             </a:r>
           </a:p>
         </p:txBody>
@@ -1574,7 +1720,7 @@
     <p:bg>
       <p:bgPr>
         <a:solidFill>
-          <a:srgbClr val="101828"/>
+          <a:srgbClr val="F4F8FC"/>
         </a:solidFill>
         <a:effectLst/>
       </p:bgPr>
@@ -1588,20 +1734,20 @@
       <p:grpSpPr/>
       <p:sp>
         <p:nvSpPr>
-          <p:cNvPr id="2" name="Accent band"/>
+          <p:cNvPr id="2" name="Brand band"/>
           <p:cNvSpPr/>
           <p:nvPr/>
         </p:nvSpPr>
         <p:spPr>
           <a:xfrm>
             <a:off x="0" y="0"/>
-            <a:ext cx="12192000" cy="91440"/>
+            <a:ext cx="12192000" cy="502920"/>
           </a:xfrm>
           <a:prstGeom prst="rect">
             <a:avLst/>
           </a:prstGeom>
           <a:solidFill>
-            <a:srgbClr val="3B82F6"/>
+            <a:srgbClr val="091F2C"/>
           </a:solidFill>
           <a:ln>
             <a:noFill/>
@@ -1610,14 +1756,36 @@
       </p:sp>
       <p:sp>
         <p:nvSpPr>
-          <p:cNvPr id="3" name="Title"/>
-          <p:cNvSpPr txBox="1"/>
-          <p:nvPr/>
-        </p:nvSpPr>
-        <p:spPr>
-          <a:xfrm>
-            <a:off x="685800" y="420000"/>
-            <a:ext cx="10820400" cy="1150000"/>
+          <p:cNvPr id="3" name="Highlight rule"/>
+          <p:cNvSpPr/>
+          <p:nvPr/>
+        </p:nvSpPr>
+        <p:spPr>
+          <a:xfrm>
+            <a:off x="0" y="502920"/>
+            <a:ext cx="12192000" cy="45720"/>
+          </a:xfrm>
+          <a:prstGeom prst="rect">
+            <a:avLst/>
+          </a:prstGeom>
+          <a:solidFill>
+            <a:srgbClr val="50E6FF"/>
+          </a:solidFill>
+          <a:ln>
+            <a:noFill/>
+          </a:ln>
+        </p:spPr>
+      </p:sp>
+      <p:sp>
+        <p:nvSpPr>
+          <p:cNvPr id="4" name="Deck kicker"/>
+          <p:cNvSpPr txBox="1"/>
+          <p:nvPr/>
+        </p:nvSpPr>
+        <p:spPr>
+          <a:xfrm>
+            <a:off x="685800" y="0"/>
+            <a:ext cx="8400000" cy="502920"/>
           </a:xfrm>
           <a:prstGeom prst="rect">
             <a:avLst/>
@@ -1642,45 +1810,74 @@
               </a:spcAft>
             </a:pPr>
             <a:r>
-              <a:rPr lang="en-US" sz="2900" b="1">
+              <a:rPr lang="en-US" sz="1100" b="1" cap="all" spc="120">
                 <a:solidFill>
                   <a:srgbClr val="FFFFFF"/>
                 </a:solidFill>
               </a:rPr>
-              <a:t>2.</a:t>
-            </a:r>
-            <a:r>
-              <a:rPr lang="en-US" sz="2900" b="1">
-                <a:solidFill>
-                  <a:srgbClr val="3B82F6"/>
-                </a:solidFill>
-              </a:rPr>
-              <a:t> Observe traced work</a:t>
-            </a:r>
-          </a:p>
-        </p:txBody>
-      </p:sp>
-      <p:sp>
-        <p:nvSpPr>
-          <p:cNvPr id="4" name="Body"/>
-          <p:cNvSpPr txBox="1"/>
-          <p:nvPr/>
-        </p:nvSpPr>
-        <p:spPr>
-          <a:xfrm>
-            <a:off x="685800" y="1750000"/>
-            <a:ext cx="3900000" cy="3900000"/>
-          </a:xfrm>
-          <a:prstGeom prst="rect">
-            <a:avLst/>
-          </a:prstGeom>
-          <a:noFill/>
-          <a:ln>
-            <a:noFill/>
-          </a:ln>
-        </p:spPr>
-        <p:txBody>
-          <a:bodyPr wrap="square" lIns="182880" tIns="91440" rIns="182880" bIns="91440" anchor="t">
+              <a:t>Agent 365</a:t>
+            </a:r>
+          </a:p>
+        </p:txBody>
+      </p:sp>
+      <p:sp>
+        <p:nvSpPr>
+          <p:cNvPr id="5" name="Slide number"/>
+          <p:cNvSpPr txBox="1"/>
+          <p:nvPr/>
+        </p:nvSpPr>
+        <p:spPr>
+          <a:xfrm>
+            <a:off x="9100000" y="0"/>
+            <a:ext cx="2406400" cy="502920"/>
+          </a:xfrm>
+          <a:prstGeom prst="rect">
+            <a:avLst/>
+          </a:prstGeom>
+          <a:noFill/>
+          <a:ln>
+            <a:noFill/>
+          </a:ln>
+        </p:spPr>
+        <p:txBody>
+          <a:bodyPr wrap="square" lIns="182880" tIns="91440" rIns="182880" bIns="91440" anchor="ctr">
+            <a:normAutofit/>
+          </a:bodyPr>
+          <a:lstStyle/>
+          <a:p>
+            <a:pPr algn="r"/>
+            <a:r>
+              <a:rPr lang="en-US" sz="1100" b="1" cap="all" spc="120">
+                <a:solidFill>
+                  <a:srgbClr val="BAC0C4"/>
+                </a:solidFill>
+              </a:rPr>
+              <a:t>3 / 6</a:t>
+            </a:r>
+          </a:p>
+        </p:txBody>
+      </p:sp>
+      <p:sp>
+        <p:nvSpPr>
+          <p:cNvPr id="6" name="Title"/>
+          <p:cNvSpPr txBox="1"/>
+          <p:nvPr/>
+        </p:nvSpPr>
+        <p:spPr>
+          <a:xfrm>
+            <a:off x="685800" y="700000"/>
+            <a:ext cx="10820400" cy="1150000"/>
+          </a:xfrm>
+          <a:prstGeom prst="rect">
+            <a:avLst/>
+          </a:prstGeom>
+          <a:noFill/>
+          <a:ln>
+            <a:noFill/>
+          </a:ln>
+        </p:spPr>
+        <p:txBody>
+          <a:bodyPr wrap="square" lIns="182880" tIns="91440" rIns="182880" bIns="91440" anchor="ctr">
             <a:normAutofit/>
           </a:bodyPr>
           <a:lstStyle/>
@@ -1694,77 +1891,36 @@
               </a:spcAft>
             </a:pPr>
             <a:r>
-              <a:rPr lang="en-US" sz="2500">
-                <a:solidFill>
-                  <a:srgbClr val="FFFFFF"/>
-                </a:solidFill>
-              </a:rPr>
-              <a:t>Observe with a registry, activity, and health first. Add telemetry so each request, model step, tool call, and error has a trace for operators, not guesswork.</a:t>
-            </a:r>
-          </a:p>
-        </p:txBody>
-      </p:sp>
-      <p:sp>
-        <p:nvSpPr>
-          <p:cNvPr id="5" name="Accent rule"/>
-          <p:cNvSpPr/>
-          <p:nvPr/>
-        </p:nvSpPr>
-        <p:spPr>
-          <a:xfrm>
-            <a:off x="548640" y="1800000"/>
-            <a:ext cx="45720" cy="3800000"/>
-          </a:xfrm>
-          <a:prstGeom prst="rect">
-            <a:avLst/>
-          </a:prstGeom>
-          <a:solidFill>
-            <a:srgbClr val="3B82F6"/>
-          </a:solidFill>
-          <a:ln>
-            <a:noFill/>
-          </a:ln>
-        </p:spPr>
-      </p:sp>
-      <p:pic>
-        <p:nvPicPr>
-          <p:cNvPr id="6" name="Asset visual-observe-traces" descr="Inventory plus telemetry turns agent activity into traceable evidence. (excalidraw diagram)"/>
-          <p:cNvPicPr>
-            <a:picLocks noChangeAspect="1"/>
-          </p:cNvPicPr>
-          <p:nvPr/>
-        </p:nvPicPr>
-        <p:blipFill>
-          <a:blip r:embed="rIdImage1"/>
-          <a:stretch>
-            <a:fillRect/>
-          </a:stretch>
-        </p:blipFill>
-        <p:spPr>
-          <a:xfrm>
-            <a:off x="5000000" y="2021875"/>
-            <a:ext cx="6500000" cy="3656250"/>
-          </a:xfrm>
-          <a:prstGeom prst="rect">
-            <a:avLst/>
-          </a:prstGeom>
-          <a:ln>
-            <a:solidFill>
-              <a:srgbClr val="D9D9D9"/>
-            </a:solidFill>
-          </a:ln>
-        </p:spPr>
-      </p:pic>
-      <p:sp>
-        <p:nvSpPr>
-          <p:cNvPr id="7" name="Footer"/>
-          <p:cNvSpPr txBox="1"/>
-          <p:nvPr/>
-        </p:nvSpPr>
-        <p:spPr>
-          <a:xfrm>
-            <a:off x="685800" y="6250000"/>
-            <a:ext cx="9400000" cy="420000"/>
+              <a:rPr lang="en-US" sz="2900" b="1">
+                <a:solidFill>
+                  <a:srgbClr val="071923"/>
+                </a:solidFill>
+                <a:latin typeface="+mj-lt"/>
+              </a:rPr>
+              <a:t>2.</a:t>
+            </a:r>
+            <a:r>
+              <a:rPr lang="en-US" sz="2900" b="1">
+                <a:solidFill>
+                  <a:srgbClr val="0067B8"/>
+                </a:solidFill>
+                <a:latin typeface="+mj-lt"/>
+              </a:rPr>
+              <a:t> Observe traced work</a:t>
+            </a:r>
+          </a:p>
+        </p:txBody>
+      </p:sp>
+      <p:sp>
+        <p:nvSpPr>
+          <p:cNvPr id="7" name="Body"/>
+          <p:cNvSpPr txBox="1"/>
+          <p:nvPr/>
+        </p:nvSpPr>
+        <p:spPr>
+          <a:xfrm>
+            <a:off x="685800" y="1950000"/>
+            <a:ext cx="3900000" cy="3900000"/>
           </a:xfrm>
           <a:prstGeom prst="rect">
             <a:avLst/>
@@ -1789,26 +1945,77 @@
               </a:spcAft>
             </a:pPr>
             <a:r>
-              <a:rPr lang="en-US" sz="1000">
-                <a:solidFill>
-                  <a:srgbClr val="BCBEC3"/>
-                </a:solidFill>
-              </a:rPr>
-              <a:t>Sources: Microsoft Agent 365 overview  ·  Microsoft Agent 365 SDK and CLI</a:t>
-            </a:r>
-          </a:p>
-        </p:txBody>
-      </p:sp>
-      <p:sp>
-        <p:nvSpPr>
-          <p:cNvPr id="8" name="Slide number"/>
-          <p:cNvSpPr txBox="1"/>
-          <p:nvPr/>
-        </p:nvSpPr>
-        <p:spPr>
-          <a:xfrm>
-            <a:off x="10100000" y="6250000"/>
-            <a:ext cx="1400000" cy="420000"/>
+              <a:rPr lang="en-US" sz="2500">
+                <a:solidFill>
+                  <a:srgbClr val="071923"/>
+                </a:solidFill>
+              </a:rPr>
+              <a:t>Observe with a registry, activity, and health first. Add telemetry so each request, model step, tool call, and error has a trace for operators, not guesswork.</a:t>
+            </a:r>
+          </a:p>
+        </p:txBody>
+      </p:sp>
+      <p:sp>
+        <p:nvSpPr>
+          <p:cNvPr id="8" name="Accent rule"/>
+          <p:cNvSpPr/>
+          <p:nvPr/>
+        </p:nvSpPr>
+        <p:spPr>
+          <a:xfrm>
+            <a:off x="548640" y="2000000"/>
+            <a:ext cx="45720" cy="3800000"/>
+          </a:xfrm>
+          <a:prstGeom prst="rect">
+            <a:avLst/>
+          </a:prstGeom>
+          <a:solidFill>
+            <a:srgbClr val="0067B8"/>
+          </a:solidFill>
+          <a:ln>
+            <a:noFill/>
+          </a:ln>
+        </p:spPr>
+      </p:sp>
+      <p:pic>
+        <p:nvPicPr>
+          <p:cNvPr id="9" name="Asset visual-observe-traces" descr="Inventory plus telemetry turns agent activity into traceable evidence. (excalidraw diagram)"/>
+          <p:cNvPicPr>
+            <a:picLocks noChangeAspect="1"/>
+          </p:cNvPicPr>
+          <p:nvPr/>
+        </p:nvPicPr>
+        <p:blipFill>
+          <a:blip r:embed="rIdImage1"/>
+          <a:stretch>
+            <a:fillRect/>
+          </a:stretch>
+        </p:blipFill>
+        <p:spPr>
+          <a:xfrm>
+            <a:off x="5000000" y="2221875"/>
+            <a:ext cx="6500000" cy="3656250"/>
+          </a:xfrm>
+          <a:prstGeom prst="rect">
+            <a:avLst/>
+          </a:prstGeom>
+          <a:ln>
+            <a:solidFill>
+              <a:srgbClr val="D9D9D9"/>
+            </a:solidFill>
+          </a:ln>
+        </p:spPr>
+      </p:pic>
+      <p:sp>
+        <p:nvSpPr>
+          <p:cNvPr id="10" name="Footer"/>
+          <p:cNvSpPr txBox="1"/>
+          <p:nvPr/>
+        </p:nvSpPr>
+        <p:spPr>
+          <a:xfrm>
+            <a:off x="685800" y="6250000"/>
+            <a:ext cx="10820400" cy="420000"/>
           </a:xfrm>
           <a:prstGeom prst="rect">
             <a:avLst/>
@@ -1824,14 +2031,21 @@
           </a:bodyPr>
           <a:lstStyle/>
           <a:p>
-            <a:pPr algn="r"/>
+            <a:pPr algn="l">
+              <a:lnSpc>
+                <a:spcPct val="105000"/>
+              </a:lnSpc>
+              <a:spcAft>
+                <a:spcPts val="0"/>
+              </a:spcAft>
+            </a:pPr>
             <a:r>
               <a:rPr lang="en-US" sz="1000">
                 <a:solidFill>
-                  <a:srgbClr val="BCBEC3"/>
-                </a:solidFill>
-              </a:rPr>
-              <a:t>3 / 6</a:t>
+                  <a:srgbClr val="626C71"/>
+                </a:solidFill>
+              </a:rPr>
+              <a:t>Sources: Microsoft Agent 365 overview  ·  Microsoft Agent 365 SDK and CLI</a:t>
             </a:r>
           </a:p>
         </p:txBody>
@@ -1850,7 +2064,7 @@
     <p:bg>
       <p:bgPr>
         <a:solidFill>
-          <a:srgbClr val="101828"/>
+          <a:srgbClr val="F4F8FC"/>
         </a:solidFill>
         <a:effectLst/>
       </p:bgPr>
@@ -1864,20 +2078,20 @@
       <p:grpSpPr/>
       <p:sp>
         <p:nvSpPr>
-          <p:cNvPr id="2" name="Accent band"/>
+          <p:cNvPr id="2" name="Brand band"/>
           <p:cNvSpPr/>
           <p:nvPr/>
         </p:nvSpPr>
         <p:spPr>
           <a:xfrm>
             <a:off x="0" y="0"/>
-            <a:ext cx="12192000" cy="91440"/>
+            <a:ext cx="12192000" cy="502920"/>
           </a:xfrm>
           <a:prstGeom prst="rect">
             <a:avLst/>
           </a:prstGeom>
           <a:solidFill>
-            <a:srgbClr val="3B82F6"/>
+            <a:srgbClr val="091F2C"/>
           </a:solidFill>
           <a:ln>
             <a:noFill/>
@@ -1886,14 +2100,36 @@
       </p:sp>
       <p:sp>
         <p:nvSpPr>
-          <p:cNvPr id="3" name="Title"/>
-          <p:cNvSpPr txBox="1"/>
-          <p:nvPr/>
-        </p:nvSpPr>
-        <p:spPr>
-          <a:xfrm>
-            <a:off x="685800" y="420000"/>
-            <a:ext cx="10820400" cy="1150000"/>
+          <p:cNvPr id="3" name="Highlight rule"/>
+          <p:cNvSpPr/>
+          <p:nvPr/>
+        </p:nvSpPr>
+        <p:spPr>
+          <a:xfrm>
+            <a:off x="0" y="502920"/>
+            <a:ext cx="12192000" cy="45720"/>
+          </a:xfrm>
+          <a:prstGeom prst="rect">
+            <a:avLst/>
+          </a:prstGeom>
+          <a:solidFill>
+            <a:srgbClr val="50E6FF"/>
+          </a:solidFill>
+          <a:ln>
+            <a:noFill/>
+          </a:ln>
+        </p:spPr>
+      </p:sp>
+      <p:sp>
+        <p:nvSpPr>
+          <p:cNvPr id="4" name="Deck kicker"/>
+          <p:cNvSpPr txBox="1"/>
+          <p:nvPr/>
+        </p:nvSpPr>
+        <p:spPr>
+          <a:xfrm>
+            <a:off x="685800" y="0"/>
+            <a:ext cx="8400000" cy="502920"/>
           </a:xfrm>
           <a:prstGeom prst="rect">
             <a:avLst/>
@@ -1918,45 +2154,74 @@
               </a:spcAft>
             </a:pPr>
             <a:r>
-              <a:rPr lang="en-US" sz="2900" b="1">
+              <a:rPr lang="en-US" sz="1100" b="1" cap="all" spc="120">
                 <a:solidFill>
                   <a:srgbClr val="FFFFFF"/>
                 </a:solidFill>
               </a:rPr>
-              <a:t>3.</a:t>
-            </a:r>
-            <a:r>
-              <a:rPr lang="en-US" sz="2900" b="1">
-                <a:solidFill>
-                  <a:srgbClr val="3B82F6"/>
-                </a:solidFill>
-              </a:rPr>
-              <a:t> Govern and secure access</a:t>
-            </a:r>
-          </a:p>
-        </p:txBody>
-      </p:sp>
-      <p:sp>
-        <p:nvSpPr>
-          <p:cNvPr id="4" name="Body"/>
-          <p:cNvSpPr txBox="1"/>
-          <p:nvPr/>
-        </p:nvSpPr>
-        <p:spPr>
-          <a:xfrm>
-            <a:off x="685800" y="1750000"/>
-            <a:ext cx="3900000" cy="3900000"/>
-          </a:xfrm>
-          <a:prstGeom prst="rect">
-            <a:avLst/>
-          </a:prstGeom>
-          <a:noFill/>
-          <a:ln>
-            <a:noFill/>
-          </a:ln>
-        </p:spPr>
-        <p:txBody>
-          <a:bodyPr wrap="square" lIns="182880" tIns="91440" rIns="182880" bIns="91440" anchor="t">
+              <a:t>Agent 365</a:t>
+            </a:r>
+          </a:p>
+        </p:txBody>
+      </p:sp>
+      <p:sp>
+        <p:nvSpPr>
+          <p:cNvPr id="5" name="Slide number"/>
+          <p:cNvSpPr txBox="1"/>
+          <p:nvPr/>
+        </p:nvSpPr>
+        <p:spPr>
+          <a:xfrm>
+            <a:off x="9100000" y="0"/>
+            <a:ext cx="2406400" cy="502920"/>
+          </a:xfrm>
+          <a:prstGeom prst="rect">
+            <a:avLst/>
+          </a:prstGeom>
+          <a:noFill/>
+          <a:ln>
+            <a:noFill/>
+          </a:ln>
+        </p:spPr>
+        <p:txBody>
+          <a:bodyPr wrap="square" lIns="182880" tIns="91440" rIns="182880" bIns="91440" anchor="ctr">
+            <a:normAutofit/>
+          </a:bodyPr>
+          <a:lstStyle/>
+          <a:p>
+            <a:pPr algn="r"/>
+            <a:r>
+              <a:rPr lang="en-US" sz="1100" b="1" cap="all" spc="120">
+                <a:solidFill>
+                  <a:srgbClr val="BAC0C4"/>
+                </a:solidFill>
+              </a:rPr>
+              <a:t>4 / 6</a:t>
+            </a:r>
+          </a:p>
+        </p:txBody>
+      </p:sp>
+      <p:sp>
+        <p:nvSpPr>
+          <p:cNvPr id="6" name="Title"/>
+          <p:cNvSpPr txBox="1"/>
+          <p:nvPr/>
+        </p:nvSpPr>
+        <p:spPr>
+          <a:xfrm>
+            <a:off x="685800" y="700000"/>
+            <a:ext cx="10820400" cy="1150000"/>
+          </a:xfrm>
+          <a:prstGeom prst="rect">
+            <a:avLst/>
+          </a:prstGeom>
+          <a:noFill/>
+          <a:ln>
+            <a:noFill/>
+          </a:ln>
+        </p:spPr>
+        <p:txBody>
+          <a:bodyPr wrap="square" lIns="182880" tIns="91440" rIns="182880" bIns="91440" anchor="ctr">
             <a:normAutofit/>
           </a:bodyPr>
           <a:lstStyle/>
@@ -1970,77 +2235,36 @@
               </a:spcAft>
             </a:pPr>
             <a:r>
-              <a:rPr lang="en-US" sz="2500">
-                <a:solidFill>
-                  <a:srgbClr val="FFFFFF"/>
-                </a:solidFill>
-              </a:rPr>
-              <a:t>Govern and secure access as one path. Pair lifecycle review, Entra controls, Purview data checks, and Defender signals for every agent before wider rollout.</a:t>
-            </a:r>
-          </a:p>
-        </p:txBody>
-      </p:sp>
-      <p:sp>
-        <p:nvSpPr>
-          <p:cNvPr id="5" name="Accent rule"/>
-          <p:cNvSpPr/>
-          <p:nvPr/>
-        </p:nvSpPr>
-        <p:spPr>
-          <a:xfrm>
-            <a:off x="548640" y="1800000"/>
-            <a:ext cx="45720" cy="3800000"/>
-          </a:xfrm>
-          <a:prstGeom prst="rect">
-            <a:avLst/>
-          </a:prstGeom>
-          <a:solidFill>
-            <a:srgbClr val="3B82F6"/>
-          </a:solidFill>
-          <a:ln>
-            <a:noFill/>
-          </a:ln>
-        </p:spPr>
-      </p:sp>
-      <p:pic>
-        <p:nvPicPr>
-          <p:cNvPr id="6" name="Asset visual-govern-secure" descr="Use the Microsoft control stack as one governed access path. (marp diagram)"/>
-          <p:cNvPicPr>
-            <a:picLocks noChangeAspect="1"/>
-          </p:cNvPicPr>
-          <p:nvPr/>
-        </p:nvPicPr>
-        <p:blipFill>
-          <a:blip r:embed="rIdImage1"/>
-          <a:stretch>
-            <a:fillRect/>
-          </a:stretch>
-        </p:blipFill>
-        <p:spPr>
-          <a:xfrm>
-            <a:off x="5000000" y="2021875"/>
-            <a:ext cx="6500000" cy="3656250"/>
-          </a:xfrm>
-          <a:prstGeom prst="rect">
-            <a:avLst/>
-          </a:prstGeom>
-          <a:ln>
-            <a:solidFill>
-              <a:srgbClr val="D9D9D9"/>
-            </a:solidFill>
-          </a:ln>
-        </p:spPr>
-      </p:pic>
-      <p:sp>
-        <p:nvSpPr>
-          <p:cNvPr id="7" name="Footer"/>
-          <p:cNvSpPr txBox="1"/>
-          <p:nvPr/>
-        </p:nvSpPr>
-        <p:spPr>
-          <a:xfrm>
-            <a:off x="685800" y="6250000"/>
-            <a:ext cx="9400000" cy="420000"/>
+              <a:rPr lang="en-US" sz="2900" b="1">
+                <a:solidFill>
+                  <a:srgbClr val="071923"/>
+                </a:solidFill>
+                <a:latin typeface="+mj-lt"/>
+              </a:rPr>
+              <a:t>3.</a:t>
+            </a:r>
+            <a:r>
+              <a:rPr lang="en-US" sz="2900" b="1">
+                <a:solidFill>
+                  <a:srgbClr val="0067B8"/>
+                </a:solidFill>
+                <a:latin typeface="+mj-lt"/>
+              </a:rPr>
+              <a:t> Govern and secure access</a:t>
+            </a:r>
+          </a:p>
+        </p:txBody>
+      </p:sp>
+      <p:sp>
+        <p:nvSpPr>
+          <p:cNvPr id="7" name="Body"/>
+          <p:cNvSpPr txBox="1"/>
+          <p:nvPr/>
+        </p:nvSpPr>
+        <p:spPr>
+          <a:xfrm>
+            <a:off x="685800" y="1950000"/>
+            <a:ext cx="3900000" cy="3900000"/>
           </a:xfrm>
           <a:prstGeom prst="rect">
             <a:avLst/>
@@ -2065,26 +2289,77 @@
               </a:spcAft>
             </a:pPr>
             <a:r>
-              <a:rPr lang="en-US" sz="1000">
-                <a:solidFill>
-                  <a:srgbClr val="BCBEC3"/>
-                </a:solidFill>
-              </a:rPr>
-              <a:t>Sources: Microsoft Agent 365 overview</a:t>
-            </a:r>
-          </a:p>
-        </p:txBody>
-      </p:sp>
-      <p:sp>
-        <p:nvSpPr>
-          <p:cNvPr id="8" name="Slide number"/>
-          <p:cNvSpPr txBox="1"/>
-          <p:nvPr/>
-        </p:nvSpPr>
-        <p:spPr>
-          <a:xfrm>
-            <a:off x="10100000" y="6250000"/>
-            <a:ext cx="1400000" cy="420000"/>
+              <a:rPr lang="en-US" sz="2500">
+                <a:solidFill>
+                  <a:srgbClr val="071923"/>
+                </a:solidFill>
+              </a:rPr>
+              <a:t>Govern and secure access as one path. Pair lifecycle review, Entra controls, Purview data checks, and Defender signals for every agent before wider rollout.</a:t>
+            </a:r>
+          </a:p>
+        </p:txBody>
+      </p:sp>
+      <p:sp>
+        <p:nvSpPr>
+          <p:cNvPr id="8" name="Accent rule"/>
+          <p:cNvSpPr/>
+          <p:nvPr/>
+        </p:nvSpPr>
+        <p:spPr>
+          <a:xfrm>
+            <a:off x="548640" y="2000000"/>
+            <a:ext cx="45720" cy="3800000"/>
+          </a:xfrm>
+          <a:prstGeom prst="rect">
+            <a:avLst/>
+          </a:prstGeom>
+          <a:solidFill>
+            <a:srgbClr val="0067B8"/>
+          </a:solidFill>
+          <a:ln>
+            <a:noFill/>
+          </a:ln>
+        </p:spPr>
+      </p:sp>
+      <p:pic>
+        <p:nvPicPr>
+          <p:cNvPr id="9" name="Asset visual-govern-secure" descr="Use the Microsoft control stack as one governed access path. (marp diagram)"/>
+          <p:cNvPicPr>
+            <a:picLocks noChangeAspect="1"/>
+          </p:cNvPicPr>
+          <p:nvPr/>
+        </p:nvPicPr>
+        <p:blipFill>
+          <a:blip r:embed="rIdImage1"/>
+          <a:stretch>
+            <a:fillRect/>
+          </a:stretch>
+        </p:blipFill>
+        <p:spPr>
+          <a:xfrm>
+            <a:off x="5000000" y="2221875"/>
+            <a:ext cx="6500000" cy="3656250"/>
+          </a:xfrm>
+          <a:prstGeom prst="rect">
+            <a:avLst/>
+          </a:prstGeom>
+          <a:ln>
+            <a:solidFill>
+              <a:srgbClr val="D9D9D9"/>
+            </a:solidFill>
+          </a:ln>
+        </p:spPr>
+      </p:pic>
+      <p:sp>
+        <p:nvSpPr>
+          <p:cNvPr id="10" name="Footer"/>
+          <p:cNvSpPr txBox="1"/>
+          <p:nvPr/>
+        </p:nvSpPr>
+        <p:spPr>
+          <a:xfrm>
+            <a:off x="685800" y="6250000"/>
+            <a:ext cx="10820400" cy="420000"/>
           </a:xfrm>
           <a:prstGeom prst="rect">
             <a:avLst/>
@@ -2100,14 +2375,21 @@
           </a:bodyPr>
           <a:lstStyle/>
           <a:p>
-            <a:pPr algn="r"/>
+            <a:pPr algn="l">
+              <a:lnSpc>
+                <a:spcPct val="105000"/>
+              </a:lnSpc>
+              <a:spcAft>
+                <a:spcPts val="0"/>
+              </a:spcAft>
+            </a:pPr>
             <a:r>
               <a:rPr lang="en-US" sz="1000">
                 <a:solidFill>
-                  <a:srgbClr val="BCBEC3"/>
-                </a:solidFill>
-              </a:rPr>
-              <a:t>4 / 6</a:t>
+                  <a:srgbClr val="626C71"/>
+                </a:solidFill>
+              </a:rPr>
+              <a:t>Sources: Microsoft Agent 365 overview</a:t>
             </a:r>
           </a:p>
         </p:txBody>
@@ -2126,7 +2408,7 @@
     <p:bg>
       <p:bgPr>
         <a:solidFill>
-          <a:srgbClr val="101828"/>
+          <a:srgbClr val="F4F8FC"/>
         </a:solidFill>
         <a:effectLst/>
       </p:bgPr>
@@ -2140,20 +2422,20 @@
       <p:grpSpPr/>
       <p:sp>
         <p:nvSpPr>
-          <p:cNvPr id="2" name="Accent band"/>
+          <p:cNvPr id="2" name="Brand band"/>
           <p:cNvSpPr/>
           <p:nvPr/>
         </p:nvSpPr>
         <p:spPr>
           <a:xfrm>
             <a:off x="0" y="0"/>
-            <a:ext cx="12192000" cy="91440"/>
+            <a:ext cx="12192000" cy="502920"/>
           </a:xfrm>
           <a:prstGeom prst="rect">
             <a:avLst/>
           </a:prstGeom>
           <a:solidFill>
-            <a:srgbClr val="3B82F6"/>
+            <a:srgbClr val="091F2C"/>
           </a:solidFill>
           <a:ln>
             <a:noFill/>
@@ -2162,14 +2444,36 @@
       </p:sp>
       <p:sp>
         <p:nvSpPr>
-          <p:cNvPr id="3" name="Title"/>
-          <p:cNvSpPr txBox="1"/>
-          <p:nvPr/>
-        </p:nvSpPr>
-        <p:spPr>
-          <a:xfrm>
-            <a:off x="685800" y="420000"/>
-            <a:ext cx="10820400" cy="1150000"/>
+          <p:cNvPr id="3" name="Highlight rule"/>
+          <p:cNvSpPr/>
+          <p:nvPr/>
+        </p:nvSpPr>
+        <p:spPr>
+          <a:xfrm>
+            <a:off x="0" y="502920"/>
+            <a:ext cx="12192000" cy="45720"/>
+          </a:xfrm>
+          <a:prstGeom prst="rect">
+            <a:avLst/>
+          </a:prstGeom>
+          <a:solidFill>
+            <a:srgbClr val="50E6FF"/>
+          </a:solidFill>
+          <a:ln>
+            <a:noFill/>
+          </a:ln>
+        </p:spPr>
+      </p:sp>
+      <p:sp>
+        <p:nvSpPr>
+          <p:cNvPr id="4" name="Deck kicker"/>
+          <p:cNvSpPr txBox="1"/>
+          <p:nvPr/>
+        </p:nvSpPr>
+        <p:spPr>
+          <a:xfrm>
+            <a:off x="685800" y="0"/>
+            <a:ext cx="8400000" cy="502920"/>
           </a:xfrm>
           <a:prstGeom prst="rect">
             <a:avLst/>
@@ -2194,45 +2498,74 @@
               </a:spcAft>
             </a:pPr>
             <a:r>
-              <a:rPr lang="en-US" sz="2900" b="1">
+              <a:rPr lang="en-US" sz="1100" b="1" cap="all" spc="120">
                 <a:solidFill>
                   <a:srgbClr val="FFFFFF"/>
                 </a:solidFill>
               </a:rPr>
-              <a:t>4.</a:t>
-            </a:r>
-            <a:r>
-              <a:rPr lang="en-US" sz="2900" b="1">
-                <a:solidFill>
-                  <a:srgbClr val="3B82F6"/>
-                </a:solidFill>
-              </a:rPr>
-              <a:t> Pilot before expansion</a:t>
-            </a:r>
-          </a:p>
-        </p:txBody>
-      </p:sp>
-      <p:sp>
-        <p:nvSpPr>
-          <p:cNvPr id="4" name="Body"/>
-          <p:cNvSpPr txBox="1"/>
-          <p:nvPr/>
-        </p:nvSpPr>
-        <p:spPr>
-          <a:xfrm>
-            <a:off x="685800" y="1750000"/>
-            <a:ext cx="3900000" cy="3900000"/>
-          </a:xfrm>
-          <a:prstGeom prst="rect">
-            <a:avLst/>
-          </a:prstGeom>
-          <a:noFill/>
-          <a:ln>
-            <a:noFill/>
-          </a:ln>
-        </p:spPr>
-        <p:txBody>
-          <a:bodyPr wrap="square" lIns="182880" tIns="91440" rIns="182880" bIns="91440" anchor="t">
+              <a:t>Agent 365</a:t>
+            </a:r>
+          </a:p>
+        </p:txBody>
+      </p:sp>
+      <p:sp>
+        <p:nvSpPr>
+          <p:cNvPr id="5" name="Slide number"/>
+          <p:cNvSpPr txBox="1"/>
+          <p:nvPr/>
+        </p:nvSpPr>
+        <p:spPr>
+          <a:xfrm>
+            <a:off x="9100000" y="0"/>
+            <a:ext cx="2406400" cy="502920"/>
+          </a:xfrm>
+          <a:prstGeom prst="rect">
+            <a:avLst/>
+          </a:prstGeom>
+          <a:noFill/>
+          <a:ln>
+            <a:noFill/>
+          </a:ln>
+        </p:spPr>
+        <p:txBody>
+          <a:bodyPr wrap="square" lIns="182880" tIns="91440" rIns="182880" bIns="91440" anchor="ctr">
+            <a:normAutofit/>
+          </a:bodyPr>
+          <a:lstStyle/>
+          <a:p>
+            <a:pPr algn="r"/>
+            <a:r>
+              <a:rPr lang="en-US" sz="1100" b="1" cap="all" spc="120">
+                <a:solidFill>
+                  <a:srgbClr val="BAC0C4"/>
+                </a:solidFill>
+              </a:rPr>
+              <a:t>5 / 6</a:t>
+            </a:r>
+          </a:p>
+        </p:txBody>
+      </p:sp>
+      <p:sp>
+        <p:nvSpPr>
+          <p:cNvPr id="6" name="Title"/>
+          <p:cNvSpPr txBox="1"/>
+          <p:nvPr/>
+        </p:nvSpPr>
+        <p:spPr>
+          <a:xfrm>
+            <a:off x="685800" y="700000"/>
+            <a:ext cx="10820400" cy="1150000"/>
+          </a:xfrm>
+          <a:prstGeom prst="rect">
+            <a:avLst/>
+          </a:prstGeom>
+          <a:noFill/>
+          <a:ln>
+            <a:noFill/>
+          </a:ln>
+        </p:spPr>
+        <p:txBody>
+          <a:bodyPr wrap="square" lIns="182880" tIns="91440" rIns="182880" bIns="91440" anchor="ctr">
             <a:normAutofit/>
           </a:bodyPr>
           <a:lstStyle/>
@@ -2246,77 +2579,36 @@
               </a:spcAft>
             </a:pPr>
             <a:r>
-              <a:rPr lang="en-US" sz="2500">
-                <a:solidFill>
-                  <a:srgbClr val="FFFFFF"/>
-                </a:solidFill>
-              </a:rPr>
-              <a:t>Keep the current agent and add only needed SDK pieces. Pilot one owned use case, verify licenses and preview limits, then scale only from evidence and review.</a:t>
-            </a:r>
-          </a:p>
-        </p:txBody>
-      </p:sp>
-      <p:sp>
-        <p:nvSpPr>
-          <p:cNvPr id="5" name="Accent rule"/>
-          <p:cNvSpPr/>
-          <p:nvPr/>
-        </p:nvSpPr>
-        <p:spPr>
-          <a:xfrm>
-            <a:off x="548640" y="1800000"/>
-            <a:ext cx="45720" cy="3800000"/>
-          </a:xfrm>
-          <a:prstGeom prst="rect">
-            <a:avLst/>
-          </a:prstGeom>
-          <a:solidFill>
-            <a:srgbClr val="3B82F6"/>
-          </a:solidFill>
-          <a:ln>
-            <a:noFill/>
-          </a:ln>
-        </p:spPr>
-      </p:sp>
-      <p:pic>
-        <p:nvPicPr>
-          <p:cNvPr id="6" name="Asset visual-accountable-pilot" descr="Start small, prove the controls, and expand only from evidence. (mermaid diagram)"/>
-          <p:cNvPicPr>
-            <a:picLocks noChangeAspect="1"/>
-          </p:cNvPicPr>
-          <p:nvPr/>
-        </p:nvPicPr>
-        <p:blipFill>
-          <a:blip r:embed="rIdImage1"/>
-          <a:stretch>
-            <a:fillRect/>
-          </a:stretch>
-        </p:blipFill>
-        <p:spPr>
-          <a:xfrm>
-            <a:off x="5000000" y="2021875"/>
-            <a:ext cx="6500000" cy="3656250"/>
-          </a:xfrm>
-          <a:prstGeom prst="rect">
-            <a:avLst/>
-          </a:prstGeom>
-          <a:ln>
-            <a:solidFill>
-              <a:srgbClr val="D9D9D9"/>
-            </a:solidFill>
-          </a:ln>
-        </p:spPr>
-      </p:pic>
-      <p:sp>
-        <p:nvSpPr>
-          <p:cNvPr id="7" name="Footer"/>
-          <p:cNvSpPr txBox="1"/>
-          <p:nvPr/>
-        </p:nvSpPr>
-        <p:spPr>
-          <a:xfrm>
-            <a:off x="685800" y="6250000"/>
-            <a:ext cx="9400000" cy="420000"/>
+              <a:rPr lang="en-US" sz="2900" b="1">
+                <a:solidFill>
+                  <a:srgbClr val="071923"/>
+                </a:solidFill>
+                <a:latin typeface="+mj-lt"/>
+              </a:rPr>
+              <a:t>4.</a:t>
+            </a:r>
+            <a:r>
+              <a:rPr lang="en-US" sz="2900" b="1">
+                <a:solidFill>
+                  <a:srgbClr val="0067B8"/>
+                </a:solidFill>
+                <a:latin typeface="+mj-lt"/>
+              </a:rPr>
+              <a:t> Pilot before expansion</a:t>
+            </a:r>
+          </a:p>
+        </p:txBody>
+      </p:sp>
+      <p:sp>
+        <p:nvSpPr>
+          <p:cNvPr id="7" name="Body"/>
+          <p:cNvSpPr txBox="1"/>
+          <p:nvPr/>
+        </p:nvSpPr>
+        <p:spPr>
+          <a:xfrm>
+            <a:off x="685800" y="1950000"/>
+            <a:ext cx="3900000" cy="3900000"/>
           </a:xfrm>
           <a:prstGeom prst="rect">
             <a:avLst/>
@@ -2341,26 +2633,77 @@
               </a:spcAft>
             </a:pPr>
             <a:r>
-              <a:rPr lang="en-US" sz="1000">
-                <a:solidFill>
-                  <a:srgbClr val="BCBEC3"/>
-                </a:solidFill>
-              </a:rPr>
-              <a:t>Sources: Microsoft Agent 365 SDK and CLI  ·  Quickstart: Connect an Existing Agent to Agent 365  ·  Microsoft Agent 365 - Service Descriptions</a:t>
-            </a:r>
-          </a:p>
-        </p:txBody>
-      </p:sp>
-      <p:sp>
-        <p:nvSpPr>
-          <p:cNvPr id="8" name="Slide number"/>
-          <p:cNvSpPr txBox="1"/>
-          <p:nvPr/>
-        </p:nvSpPr>
-        <p:spPr>
-          <a:xfrm>
-            <a:off x="10100000" y="6250000"/>
-            <a:ext cx="1400000" cy="420000"/>
+              <a:rPr lang="en-US" sz="2500">
+                <a:solidFill>
+                  <a:srgbClr val="071923"/>
+                </a:solidFill>
+              </a:rPr>
+              <a:t>Keep the current agent and add only needed SDK pieces. Pilot one owned use case, verify licenses and preview limits, then scale only from evidence and review.</a:t>
+            </a:r>
+          </a:p>
+        </p:txBody>
+      </p:sp>
+      <p:sp>
+        <p:nvSpPr>
+          <p:cNvPr id="8" name="Accent rule"/>
+          <p:cNvSpPr/>
+          <p:nvPr/>
+        </p:nvSpPr>
+        <p:spPr>
+          <a:xfrm>
+            <a:off x="548640" y="2000000"/>
+            <a:ext cx="45720" cy="3800000"/>
+          </a:xfrm>
+          <a:prstGeom prst="rect">
+            <a:avLst/>
+          </a:prstGeom>
+          <a:solidFill>
+            <a:srgbClr val="0067B8"/>
+          </a:solidFill>
+          <a:ln>
+            <a:noFill/>
+          </a:ln>
+        </p:spPr>
+      </p:sp>
+      <p:pic>
+        <p:nvPicPr>
+          <p:cNvPr id="9" name="Asset visual-accountable-pilot" descr="Start small, prove the controls, and expand only from evidence. (mermaid diagram)"/>
+          <p:cNvPicPr>
+            <a:picLocks noChangeAspect="1"/>
+          </p:cNvPicPr>
+          <p:nvPr/>
+        </p:nvPicPr>
+        <p:blipFill>
+          <a:blip r:embed="rIdImage1"/>
+          <a:stretch>
+            <a:fillRect/>
+          </a:stretch>
+        </p:blipFill>
+        <p:spPr>
+          <a:xfrm>
+            <a:off x="5000000" y="2221875"/>
+            <a:ext cx="6500000" cy="3656250"/>
+          </a:xfrm>
+          <a:prstGeom prst="rect">
+            <a:avLst/>
+          </a:prstGeom>
+          <a:ln>
+            <a:solidFill>
+              <a:srgbClr val="D9D9D9"/>
+            </a:solidFill>
+          </a:ln>
+        </p:spPr>
+      </p:pic>
+      <p:sp>
+        <p:nvSpPr>
+          <p:cNvPr id="10" name="Footer"/>
+          <p:cNvSpPr txBox="1"/>
+          <p:nvPr/>
+        </p:nvSpPr>
+        <p:spPr>
+          <a:xfrm>
+            <a:off x="685800" y="6250000"/>
+            <a:ext cx="10820400" cy="420000"/>
           </a:xfrm>
           <a:prstGeom prst="rect">
             <a:avLst/>
@@ -2376,14 +2719,21 @@
           </a:bodyPr>
           <a:lstStyle/>
           <a:p>
-            <a:pPr algn="r"/>
+            <a:pPr algn="l">
+              <a:lnSpc>
+                <a:spcPct val="105000"/>
+              </a:lnSpc>
+              <a:spcAft>
+                <a:spcPts val="0"/>
+              </a:spcAft>
+            </a:pPr>
             <a:r>
               <a:rPr lang="en-US" sz="1000">
                 <a:solidFill>
-                  <a:srgbClr val="BCBEC3"/>
-                </a:solidFill>
-              </a:rPr>
-              <a:t>5 / 6</a:t>
+                  <a:srgbClr val="626C71"/>
+                </a:solidFill>
+              </a:rPr>
+              <a:t>Sources: Microsoft Agent 365 SDK and CLI  ·  Quickstart: Connect an Existing Agent to Agent 365  ·  Microsoft Agent 365 - Service Descriptions</a:t>
             </a:r>
           </a:p>
         </p:txBody>
@@ -2402,7 +2752,7 @@
     <p:bg>
       <p:bgPr>
         <a:solidFill>
-          <a:srgbClr val="101828"/>
+          <a:srgbClr val="F4F8FC"/>
         </a:solidFill>
         <a:effectLst/>
       </p:bgPr>
@@ -2416,20 +2766,20 @@
       <p:grpSpPr/>
       <p:sp>
         <p:nvSpPr>
-          <p:cNvPr id="2" name="Accent band"/>
+          <p:cNvPr id="2" name="Brand band"/>
           <p:cNvSpPr/>
           <p:nvPr/>
         </p:nvSpPr>
         <p:spPr>
           <a:xfrm>
             <a:off x="0" y="0"/>
-            <a:ext cx="12192000" cy="91440"/>
+            <a:ext cx="12192000" cy="502920"/>
           </a:xfrm>
           <a:prstGeom prst="rect">
             <a:avLst/>
           </a:prstGeom>
           <a:solidFill>
-            <a:srgbClr val="3B82F6"/>
+            <a:srgbClr val="091F2C"/>
           </a:solidFill>
           <a:ln>
             <a:noFill/>
@@ -2438,14 +2788,36 @@
       </p:sp>
       <p:sp>
         <p:nvSpPr>
-          <p:cNvPr id="3" name="Title"/>
-          <p:cNvSpPr txBox="1"/>
-          <p:nvPr/>
-        </p:nvSpPr>
-        <p:spPr>
-          <a:xfrm>
-            <a:off x="685800" y="420000"/>
-            <a:ext cx="10820400" cy="1000000"/>
+          <p:cNvPr id="3" name="Highlight rule"/>
+          <p:cNvSpPr/>
+          <p:nvPr/>
+        </p:nvSpPr>
+        <p:spPr>
+          <a:xfrm>
+            <a:off x="0" y="502920"/>
+            <a:ext cx="12192000" cy="45720"/>
+          </a:xfrm>
+          <a:prstGeom prst="rect">
+            <a:avLst/>
+          </a:prstGeom>
+          <a:solidFill>
+            <a:srgbClr val="50E6FF"/>
+          </a:solidFill>
+          <a:ln>
+            <a:noFill/>
+          </a:ln>
+        </p:spPr>
+      </p:sp>
+      <p:sp>
+        <p:nvSpPr>
+          <p:cNvPr id="4" name="Deck kicker"/>
+          <p:cNvSpPr txBox="1"/>
+          <p:nvPr/>
+        </p:nvSpPr>
+        <p:spPr>
+          <a:xfrm>
+            <a:off x="685800" y="0"/>
+            <a:ext cx="8400000" cy="502920"/>
           </a:xfrm>
           <a:prstGeom prst="rect">
             <a:avLst/>
@@ -2470,45 +2842,74 @@
               </a:spcAft>
             </a:pPr>
             <a:r>
-              <a:rPr lang="en-US" sz="2400" b="1">
+              <a:rPr lang="en-US" sz="1100" b="1" cap="all" spc="120">
                 <a:solidFill>
                   <a:srgbClr val="FFFFFF"/>
                 </a:solidFill>
               </a:rPr>
-              <a:t>Sources.</a:t>
-            </a:r>
-            <a:r>
-              <a:rPr lang="en-US" sz="2400" b="1">
-                <a:solidFill>
-                  <a:srgbClr val="3B82F6"/>
-                </a:solidFill>
-              </a:rPr>
-              <a:t> Every claim traces to one.</a:t>
-            </a:r>
-          </a:p>
-        </p:txBody>
-      </p:sp>
-      <p:sp>
-        <p:nvSpPr>
-          <p:cNvPr id="4" name="Sources"/>
-          <p:cNvSpPr txBox="1"/>
-          <p:nvPr/>
-        </p:nvSpPr>
-        <p:spPr>
-          <a:xfrm>
-            <a:off x="685800" y="1700000"/>
-            <a:ext cx="10820400" cy="4300000"/>
-          </a:xfrm>
-          <a:prstGeom prst="rect">
-            <a:avLst/>
-          </a:prstGeom>
-          <a:noFill/>
-          <a:ln>
-            <a:noFill/>
-          </a:ln>
-        </p:spPr>
-        <p:txBody>
-          <a:bodyPr wrap="square" lIns="182880" tIns="91440" rIns="182880" bIns="91440" anchor="t">
+              <a:t>Agent 365</a:t>
+            </a:r>
+          </a:p>
+        </p:txBody>
+      </p:sp>
+      <p:sp>
+        <p:nvSpPr>
+          <p:cNvPr id="5" name="Slide number"/>
+          <p:cNvSpPr txBox="1"/>
+          <p:nvPr/>
+        </p:nvSpPr>
+        <p:spPr>
+          <a:xfrm>
+            <a:off x="9100000" y="0"/>
+            <a:ext cx="2406400" cy="502920"/>
+          </a:xfrm>
+          <a:prstGeom prst="rect">
+            <a:avLst/>
+          </a:prstGeom>
+          <a:noFill/>
+          <a:ln>
+            <a:noFill/>
+          </a:ln>
+        </p:spPr>
+        <p:txBody>
+          <a:bodyPr wrap="square" lIns="182880" tIns="91440" rIns="182880" bIns="91440" anchor="ctr">
+            <a:normAutofit/>
+          </a:bodyPr>
+          <a:lstStyle/>
+          <a:p>
+            <a:pPr algn="r"/>
+            <a:r>
+              <a:rPr lang="en-US" sz="1100" b="1" cap="all" spc="120">
+                <a:solidFill>
+                  <a:srgbClr val="BAC0C4"/>
+                </a:solidFill>
+              </a:rPr>
+              <a:t>6 / 6</a:t>
+            </a:r>
+          </a:p>
+        </p:txBody>
+      </p:sp>
+      <p:sp>
+        <p:nvSpPr>
+          <p:cNvPr id="6" name="Title"/>
+          <p:cNvSpPr txBox="1"/>
+          <p:nvPr/>
+        </p:nvSpPr>
+        <p:spPr>
+          <a:xfrm>
+            <a:off x="685800" y="760000"/>
+            <a:ext cx="10820400" cy="1000000"/>
+          </a:xfrm>
+          <a:prstGeom prst="rect">
+            <a:avLst/>
+          </a:prstGeom>
+          <a:noFill/>
+          <a:ln>
+            <a:noFill/>
+          </a:ln>
+        </p:spPr>
+        <p:txBody>
+          <a:bodyPr wrap="square" lIns="182880" tIns="91440" rIns="182880" bIns="91440" anchor="ctr">
             <a:normAutofit/>
           </a:bodyPr>
           <a:lstStyle/>
@@ -2522,9 +2923,63 @@
               </a:spcAft>
             </a:pPr>
             <a:r>
+              <a:rPr lang="en-US" sz="2400" b="1">
+                <a:solidFill>
+                  <a:srgbClr val="071923"/>
+                </a:solidFill>
+                <a:latin typeface="+mj-lt"/>
+              </a:rPr>
+              <a:t>Sources.</a:t>
+            </a:r>
+            <a:r>
+              <a:rPr lang="en-US" sz="2400" b="1">
+                <a:solidFill>
+                  <a:srgbClr val="0067B8"/>
+                </a:solidFill>
+                <a:latin typeface="+mj-lt"/>
+              </a:rPr>
+              <a:t> Every claim traces to one.</a:t>
+            </a:r>
+          </a:p>
+        </p:txBody>
+      </p:sp>
+      <p:sp>
+        <p:nvSpPr>
+          <p:cNvPr id="7" name="Sources"/>
+          <p:cNvSpPr txBox="1"/>
+          <p:nvPr/>
+        </p:nvSpPr>
+        <p:spPr>
+          <a:xfrm>
+            <a:off x="685800" y="1900000"/>
+            <a:ext cx="10820400" cy="4300000"/>
+          </a:xfrm>
+          <a:prstGeom prst="rect">
+            <a:avLst/>
+          </a:prstGeom>
+          <a:noFill/>
+          <a:ln>
+            <a:noFill/>
+          </a:ln>
+        </p:spPr>
+        <p:txBody>
+          <a:bodyPr wrap="square" lIns="182880" tIns="91440" rIns="182880" bIns="91440" anchor="t">
+            <a:normAutofit/>
+          </a:bodyPr>
+          <a:lstStyle/>
+          <a:p>
+            <a:pPr algn="l">
+              <a:lnSpc>
+                <a:spcPct val="105000"/>
+              </a:lnSpc>
+              <a:spcAft>
+                <a:spcPts val="0"/>
+              </a:spcAft>
+            </a:pPr>
+            <a:r>
               <a:rPr lang="en-US" sz="1400" b="1">
                 <a:solidFill>
-                  <a:srgbClr val="FFFFFF"/>
+                  <a:srgbClr val="071923"/>
                 </a:solidFill>
               </a:rPr>
               <a:t>Microsoft Agent 365 - Service Descriptions</a:t>
@@ -2532,7 +2987,7 @@
             <a:r>
               <a:rPr lang="en-US" sz="1100">
                 <a:solidFill>
-                  <a:srgbClr val="BCBEC3"/>
+                  <a:srgbClr val="626C71"/>
                 </a:solidFill>
               </a:rPr>
               <a:t>  retrieved 2026-10-06</a:t>
@@ -2550,7 +3005,7 @@
             <a:r>
               <a:rPr lang="en-US" sz="1100">
                 <a:solidFill>
-                  <a:srgbClr val="3B82F6"/>
+                  <a:srgbClr val="0067B8"/>
                 </a:solidFill>
               </a:rPr>
               <a:t>https://learn.microsoft.com/en-us/office365/servicedescriptions/microsoft-agent-365/microsoft-agent-365</a:t>
@@ -2568,7 +3023,7 @@
             <a:r>
               <a:rPr lang="en-US" sz="1400" b="1">
                 <a:solidFill>
-                  <a:srgbClr val="FFFFFF"/>
+                  <a:srgbClr val="071923"/>
                 </a:solidFill>
               </a:rPr>
               <a:t>Microsoft Agent 365 overview</a:t>
@@ -2576,7 +3031,7 @@
             <a:r>
               <a:rPr lang="en-US" sz="1100">
                 <a:solidFill>
-                  <a:srgbClr val="BCBEC3"/>
+                  <a:srgbClr val="626C71"/>
                 </a:solidFill>
               </a:rPr>
               <a:t>  retrieved 2026-10-06</a:t>
@@ -2594,7 +3049,7 @@
             <a:r>
               <a:rPr lang="en-US" sz="1100">
                 <a:solidFill>
-                  <a:srgbClr val="3B82F6"/>
+                  <a:srgbClr val="0067B8"/>
                 </a:solidFill>
               </a:rPr>
               <a:t>https://learn.microsoft.com/en-us/microsoft-agent-365/overview</a:t>
@@ -2612,7 +3067,7 @@
             <a:r>
               <a:rPr lang="en-US" sz="1400" b="1">
                 <a:solidFill>
-                  <a:srgbClr val="FFFFFF"/>
+                  <a:srgbClr val="071923"/>
                 </a:solidFill>
               </a:rPr>
               <a:t>Microsoft Agent 365 SDK and CLI</a:t>
@@ -2620,7 +3075,7 @@
             <a:r>
               <a:rPr lang="en-US" sz="1100">
                 <a:solidFill>
-                  <a:srgbClr val="BCBEC3"/>
+                  <a:srgbClr val="626C71"/>
                 </a:solidFill>
               </a:rPr>
               <a:t>  retrieved 2026-10-06</a:t>
@@ -2638,7 +3093,7 @@
             <a:r>
               <a:rPr lang="en-US" sz="1100">
                 <a:solidFill>
-                  <a:srgbClr val="3B82F6"/>
+                  <a:srgbClr val="0067B8"/>
                 </a:solidFill>
               </a:rPr>
               <a:t>https://learn.microsoft.com/en-us/microsoft-agent-365/developer/</a:t>
@@ -2656,7 +3111,7 @@
             <a:r>
               <a:rPr lang="en-US" sz="1400" b="1">
                 <a:solidFill>
-                  <a:srgbClr val="FFFFFF"/>
+                  <a:srgbClr val="071923"/>
                 </a:solidFill>
               </a:rPr>
               <a:t>Quickstart: Connect an Existing Agent to Agent 365</a:t>
@@ -2664,7 +3119,7 @@
             <a:r>
               <a:rPr lang="en-US" sz="1100">
                 <a:solidFill>
-                  <a:srgbClr val="BCBEC3"/>
+                  <a:srgbClr val="626C71"/>
                 </a:solidFill>
               </a:rPr>
               <a:t>  retrieved 2026-10-06</a:t>
@@ -2682,7 +3137,7 @@
             <a:r>
               <a:rPr lang="en-US" sz="1100">
                 <a:solidFill>
-                  <a:srgbClr val="3B82F6"/>
+                  <a:srgbClr val="0067B8"/>
                 </a:solidFill>
               </a:rPr>
               <a:t>https://learn.microsoft.com/en-us/microsoft-agent-365/developer/get-started</a:t>
@@ -2692,14 +3147,14 @@
       </p:sp>
       <p:sp>
         <p:nvSpPr>
-          <p:cNvPr id="5" name="Footer"/>
+          <p:cNvPr id="8" name="Footer"/>
           <p:cNvSpPr txBox="1"/>
           <p:nvPr/>
         </p:nvSpPr>
         <p:spPr>
           <a:xfrm>
             <a:off x="685800" y="6250000"/>
-            <a:ext cx="9400000" cy="420000"/>
+            <a:ext cx="10820400" cy="420000"/>
           </a:xfrm>
           <a:prstGeom prst="rect">
             <a:avLst/>
@@ -2726,47 +3181,10 @@
             <a:r>
               <a:rPr lang="en-US" sz="1000">
                 <a:solidFill>
-                  <a:srgbClr val="BCBEC3"/>
-                </a:solidFill>
-              </a:rPr>
-              <a:t>agent-365-2026-03-am-michael-kokoro-onnx</a:t>
-            </a:r>
-          </a:p>
-        </p:txBody>
-      </p:sp>
-      <p:sp>
-        <p:nvSpPr>
-          <p:cNvPr id="6" name="Slide number"/>
-          <p:cNvSpPr txBox="1"/>
-          <p:nvPr/>
-        </p:nvSpPr>
-        <p:spPr>
-          <a:xfrm>
-            <a:off x="10100000" y="6250000"/>
-            <a:ext cx="1400000" cy="420000"/>
-          </a:xfrm>
-          <a:prstGeom prst="rect">
-            <a:avLst/>
-          </a:prstGeom>
-          <a:noFill/>
-          <a:ln>
-            <a:noFill/>
-          </a:ln>
-        </p:spPr>
-        <p:txBody>
-          <a:bodyPr wrap="square" lIns="182880" tIns="91440" rIns="182880" bIns="91440" anchor="t">
-            <a:normAutofit/>
-          </a:bodyPr>
-          <a:lstStyle/>
-          <a:p>
-            <a:pPr algn="r"/>
-            <a:r>
-              <a:rPr lang="en-US" sz="1000">
-                <a:solidFill>
-                  <a:srgbClr val="BCBEC3"/>
-                </a:solidFill>
-              </a:rPr>
-              <a:t>6 / 6</a:t>
+                  <a:srgbClr val="626C71"/>
+                </a:solidFill>
+              </a:rPr>
+              <a:t>agent-365-2026-04-am-michael-kokoro-onnx</a:t>
             </a:r>
           </a:p>
         </p:txBody>
@@ -2780,59 +3198,59 @@
 </file>
 
 <file path=ppt/theme/theme1.xml><?xml version="1.0" encoding="utf-8"?>
-<a:theme xmlns:a="http://schemas.openxmlformats.org/drawingml/2006/main" name="agent365-editorial-ink">
+<a:theme xmlns:a="http://schemas.openxmlformats.org/drawingml/2006/main" name="agent-365-brand">
   <a:themeElements>
-    <a:clrScheme name="agent365-editorial-ink">
+    <a:clrScheme name="agent-365-brand">
       <a:dk1>
-        <a:srgbClr val="FFFFFF"/>
+        <a:srgbClr val="071923"/>
       </a:dk1>
       <a:lt1>
-        <a:srgbClr val="101828"/>
+        <a:srgbClr val="F4F8FC"/>
       </a:lt1>
       <a:dk2>
-        <a:srgbClr val="1F1F1F"/>
+        <a:srgbClr val="091F2C"/>
       </a:dk2>
       <a:lt2>
-        <a:srgbClr val="F8F8F8"/>
+        <a:srgbClr val="E6F0F8"/>
       </a:lt2>
       <a:accent1>
-        <a:srgbClr val="3B82F6"/>
+        <a:srgbClr val="0067B8"/>
       </a:accent1>
       <a:accent2>
-        <a:srgbClr val="5B9BD5"/>
+        <a:srgbClr val="50E6FF"/>
       </a:accent2>
       <a:accent3>
-        <a:srgbClr val="70AD47"/>
+        <a:srgbClr val="0067B8"/>
       </a:accent3>
       <a:accent4>
-        <a:srgbClr val="FFC000"/>
+        <a:srgbClr val="06141D"/>
       </a:accent4>
       <a:accent5>
-        <a:srgbClr val="C00000"/>
+        <a:srgbClr val="626C71"/>
       </a:accent5>
       <a:accent6>
-        <a:srgbClr val="7030A0"/>
+        <a:srgbClr val="B42318"/>
       </a:accent6>
       <a:hlink>
-        <a:srgbClr val="3B82F6"/>
+        <a:srgbClr val="0067B8"/>
       </a:hlink>
       <a:folHlink>
-        <a:srgbClr val="7F7F7F"/>
+        <a:srgbClr val="626C71"/>
       </a:folHlink>
     </a:clrScheme>
-    <a:fontScheme name="agent365-editorial-ink">
+    <a:fontScheme name="agent-365-brand">
       <a:majorFont>
-        <a:latin typeface="Arial"/>
+        <a:latin typeface="Segoe UI Variable Display"/>
         <a:ea typeface=""/>
         <a:cs typeface=""/>
       </a:majorFont>
       <a:minorFont>
-        <a:latin typeface="Arial"/>
+        <a:latin typeface="Segoe UI Variable Text"/>
         <a:ea typeface=""/>
         <a:cs typeface=""/>
       </a:minorFont>
     </a:fontScheme>
-    <a:fmtScheme name="agent365-editorial-ink">
+    <a:fmtScheme name="agent-365-brand">
       <a:fillStyleLst>
         <a:solidFill>
           <a:schemeClr val="phClr"/>

</xml_diff>

<commit_message>
feat: regenerate agent-365 on media adapter 13
- render four voices with source-seeded Excalidraw strokes
- add video and spatial spectrograms and internal/external alignment evidence

🎨 - Generated by Copilot

Co-authored-by: Copilot <223556219+Copilot@users.noreply.github.com>
</commit_message>
<xml_diff>
--- a/projects/agent-365/release/outputs/deck.pptx
+++ b/projects/agent-365/release/outputs/deck.pptx
@@ -1357,7 +1357,7 @@
                   <a:srgbClr val="626C71"/>
                 </a:solidFill>
               </a:rPr>
-              <a:t>agent-365-2026-04-am-michael-kokoro-onnx</a:t>
+              <a:t>agent-365-2026-05-am-michael-kokoro-onnx</a:t>
             </a:r>
           </a:p>
         </p:txBody>
@@ -3184,7 +3184,7 @@
                   <a:srgbClr val="626C71"/>
                 </a:solidFill>
               </a:rPr>
-              <a:t>agent-365-2026-04-am-michael-kokoro-onnx</a:t>
+              <a:t>agent-365-2026-05-am-michael-kokoro-onnx</a:t>
             </a:r>
           </a:p>
         </p:txBody>

</xml_diff>